<commit_message>
feat: update presentation slides for Final Report
</commit_message>
<xml_diff>
--- a/Documents/FinalReport/B23DCCE078_Slides.pptx
+++ b/Documents/FinalReport/B23DCCE078_Slides.pptx
@@ -7933,8 +7933,8 @@
         </p:nvSpPr>
         <p:spPr>
           <a:xfrm>
-            <a:off x="3029980" y="6859901"/>
-            <a:ext cx="10461460" cy="753674"/>
+            <a:off x="12801533" y="6196220"/>
+            <a:ext cx="689907" cy="1417355"/>
           </a:xfrm>
           <a:custGeom>
             <a:avLst/>
@@ -7943,46 +7943,33 @@
             <a:cxnLst/>
             <a:rect r="r" b="b" t="t" l="l"/>
             <a:pathLst>
-              <a:path h="753674" w="10461460">
+              <a:path h="1417355" w="689907">
                 <a:moveTo>
-                  <a:pt x="6728" y="0"/>
+                  <a:pt x="0" y="0"/>
                 </a:moveTo>
                 <a:lnTo>
-                  <a:pt x="3364" y="0"/>
+                  <a:pt x="0" y="1188756"/>
                 </a:lnTo>
                 <a:cubicBezTo>
-                  <a:pt x="2472" y="0"/>
-                  <a:pt x="1617" y="355"/>
-                  <a:pt x="986" y="986"/>
+                  <a:pt x="0" y="1249384"/>
+                  <a:pt x="24085" y="1307530"/>
+                  <a:pt x="66956" y="1350400"/>
                 </a:cubicBezTo>
                 <a:cubicBezTo>
-                  <a:pt x="355" y="1617"/>
-                  <a:pt x="0" y="2472"/>
-                  <a:pt x="0" y="3365"/>
+                  <a:pt x="109827" y="1393271"/>
+                  <a:pt x="167972" y="1417356"/>
+                  <a:pt x="228600" y="1417356"/>
                 </a:cubicBezTo>
                 <a:lnTo>
-                  <a:pt x="0" y="525075"/>
+                  <a:pt x="461307" y="1417356"/>
                 </a:lnTo>
                 <a:cubicBezTo>
-                  <a:pt x="0" y="585703"/>
-                  <a:pt x="24085" y="643849"/>
-                  <a:pt x="66956" y="686719"/>
+                  <a:pt x="587560" y="1417356"/>
+                  <a:pt x="689907" y="1315008"/>
+                  <a:pt x="689907" y="1188756"/>
                 </a:cubicBezTo>
-                <a:cubicBezTo>
-                  <a:pt x="109827" y="729590"/>
-                  <a:pt x="167972" y="753675"/>
-                  <a:pt x="228601" y="753675"/>
-                </a:cubicBezTo>
-                <a:lnTo>
-                  <a:pt x="10232860" y="753675"/>
-                </a:lnTo>
-                <a:cubicBezTo>
-                  <a:pt x="10359113" y="753675"/>
-                  <a:pt x="10461460" y="651327"/>
-                  <a:pt x="10461460" y="525075"/>
-                </a:cubicBezTo>
-                <a:lnTo>
-                  <a:pt x="10461460" y="0"/>
+                <a:lnTo>
+                  <a:pt x="689907" y="663681"/>
                 </a:lnTo>
               </a:path>
             </a:pathLst>
@@ -7992,7 +7979,7 @@
               <a:srgbClr val="000000"/>
             </a:solidFill>
             <a:prstDash val="solid"/>
-            <a:headEnd type="none" len="sm" w="sm"/>
+            <a:headEnd type="arrow" len="sm" w="med"/>
             <a:tailEnd type="none" len="sm" w="sm"/>
           </a:ln>
         </p:spPr>
@@ -8005,7 +7992,7 @@
         </p:nvSpPr>
         <p:spPr>
           <a:xfrm rot="0">
-            <a:off x="7361523" y="7813600"/>
+            <a:off x="12045648" y="7870750"/>
             <a:ext cx="2169557" cy="372745"/>
           </a:xfrm>
           <a:prstGeom prst="rect">
@@ -8037,6 +8024,50 @@
                 <a:sym typeface="Noto Sans"/>
               </a:rPr>
               <a:t>UI vẽ lại quân cờ</a:t>
+            </a:r>
+          </a:p>
+        </p:txBody>
+      </p:sp>
+      <p:sp>
+        <p:nvSpPr>
+          <p:cNvPr name="TextBox 30" id="30"/>
+          <p:cNvSpPr txBox="true"/>
+          <p:nvPr/>
+        </p:nvSpPr>
+        <p:spPr>
+          <a:xfrm rot="0">
+            <a:off x="8091488" y="6654478"/>
+            <a:ext cx="1102281" cy="372745"/>
+          </a:xfrm>
+          <a:prstGeom prst="rect">
+            <a:avLst/>
+          </a:prstGeom>
+        </p:spPr>
+        <p:txBody>
+          <a:bodyPr anchor="t" rtlCol="false" tIns="0" lIns="0" bIns="0" rIns="0">
+            <a:spAutoFit/>
+          </a:bodyPr>
+          <a:lstStyle/>
+          <a:p>
+            <a:pPr algn="ctr">
+              <a:lnSpc>
+                <a:spcPts val="3079"/>
+              </a:lnSpc>
+              <a:spcBef>
+                <a:spcPct val="0"/>
+              </a:spcBef>
+            </a:pPr>
+            <a:r>
+              <a:rPr lang="en-US" sz="2199">
+                <a:solidFill>
+                  <a:srgbClr val="000000"/>
+                </a:solidFill>
+                <a:latin typeface="Noto Sans"/>
+                <a:ea typeface="Noto Sans"/>
+                <a:cs typeface="Noto Sans"/>
+                <a:sym typeface="Noto Sans"/>
+              </a:rPr>
+              <a:t>server.js</a:t>
             </a:r>
           </a:p>
         </p:txBody>
@@ -14550,10 +14581,10 @@
         </p:nvGrpSpPr>
         <p:grpSpPr>
           <a:xfrm rot="0">
-            <a:off x="2291504" y="4285430"/>
-            <a:ext cx="3086100" cy="3086100"/>
+            <a:off x="831407" y="4285430"/>
+            <a:ext cx="4855513" cy="3834440"/>
             <a:chOff x="0" y="0"/>
-            <a:chExt cx="812800" cy="812800"/>
+            <a:chExt cx="1278818" cy="1009894"/>
           </a:xfrm>
         </p:grpSpPr>
         <p:sp>
@@ -14565,7 +14596,7 @@
           <p:spPr>
             <a:xfrm flipH="false" flipV="false" rot="0">
               <a:off x="0" y="0"/>
-              <a:ext cx="812800" cy="812800"/>
+              <a:ext cx="1278818" cy="1009894"/>
             </a:xfrm>
             <a:custGeom>
               <a:avLst/>
@@ -14574,18 +14605,18 @@
               <a:cxnLst/>
               <a:rect r="r" b="b" t="t" l="l"/>
               <a:pathLst>
-                <a:path h="812800" w="812800">
+                <a:path h="1009894" w="1278818">
                   <a:moveTo>
                     <a:pt x="0" y="0"/>
                   </a:moveTo>
                   <a:lnTo>
-                    <a:pt x="812800" y="0"/>
+                    <a:pt x="1278818" y="0"/>
                   </a:lnTo>
                   <a:lnTo>
-                    <a:pt x="812800" y="812800"/>
+                    <a:pt x="1278818" y="1009894"/>
                   </a:lnTo>
                   <a:lnTo>
-                    <a:pt x="0" y="812800"/>
+                    <a:pt x="0" y="1009894"/>
                   </a:lnTo>
                   <a:close/>
                 </a:path>
@@ -14605,7 +14636,7 @@
           <p:spPr>
             <a:xfrm>
               <a:off x="0" y="-38100"/>
-              <a:ext cx="812800" cy="850900"/>
+              <a:ext cx="1278818" cy="1047994"/>
             </a:xfrm>
             <a:prstGeom prst="rect">
               <a:avLst/>
@@ -14796,8 +14827,8 @@
         </p:nvSpPr>
         <p:spPr>
           <a:xfrm>
-            <a:off x="5377604" y="3956602"/>
-            <a:ext cx="5165664" cy="1871878"/>
+            <a:off x="5686920" y="3956602"/>
+            <a:ext cx="4856348" cy="2246049"/>
           </a:xfrm>
           <a:custGeom>
             <a:avLst/>
@@ -14806,38 +14837,38 @@
             <a:cxnLst/>
             <a:rect r="r" b="b" t="t" l="l"/>
             <a:pathLst>
-              <a:path h="1871878" w="5165664">
+              <a:path h="2246049" w="4856348">
                 <a:moveTo>
-                  <a:pt x="0" y="1871878"/>
+                  <a:pt x="0" y="2246048"/>
                 </a:moveTo>
                 <a:lnTo>
-                  <a:pt x="2354232" y="1871878"/>
+                  <a:pt x="2199574" y="2246048"/>
                 </a:lnTo>
                 <a:cubicBezTo>
-                  <a:pt x="2414861" y="1871878"/>
-                  <a:pt x="2473006" y="1847794"/>
-                  <a:pt x="2515876" y="1804923"/>
+                  <a:pt x="2260203" y="2246048"/>
+                  <a:pt x="2318348" y="2221964"/>
+                  <a:pt x="2361218" y="2179093"/>
                 </a:cubicBezTo>
                 <a:cubicBezTo>
-                  <a:pt x="2558747" y="1762052"/>
-                  <a:pt x="2582832" y="1703907"/>
-                  <a:pt x="2582832" y="1643278"/>
+                  <a:pt x="2404089" y="2136222"/>
+                  <a:pt x="2428174" y="2078077"/>
+                  <a:pt x="2428174" y="2017448"/>
                 </a:cubicBezTo>
                 <a:lnTo>
-                  <a:pt x="2582832" y="228600"/>
+                  <a:pt x="2428174" y="228600"/>
                 </a:lnTo>
                 <a:cubicBezTo>
-                  <a:pt x="2582832" y="167971"/>
-                  <a:pt x="2606916" y="109826"/>
-                  <a:pt x="2649787" y="66955"/>
+                  <a:pt x="2428174" y="167971"/>
+                  <a:pt x="2452258" y="109826"/>
+                  <a:pt x="2495129" y="66955"/>
                 </a:cubicBezTo>
                 <a:cubicBezTo>
-                  <a:pt x="2692658" y="24084"/>
-                  <a:pt x="2750803" y="0"/>
-                  <a:pt x="2811432" y="0"/>
+                  <a:pt x="2538000" y="24084"/>
+                  <a:pt x="2596145" y="0"/>
+                  <a:pt x="2656774" y="0"/>
                 </a:cubicBezTo>
                 <a:lnTo>
-                  <a:pt x="5165664" y="0"/>
+                  <a:pt x="4856348" y="0"/>
                 </a:lnTo>
               </a:path>
             </a:pathLst>
@@ -14860,8 +14891,8 @@
         </p:nvSpPr>
         <p:spPr>
           <a:xfrm>
-            <a:off x="5377604" y="5828480"/>
-            <a:ext cx="5165664" cy="1962470"/>
+            <a:off x="5686920" y="6202650"/>
+            <a:ext cx="4856348" cy="1588300"/>
           </a:xfrm>
           <a:custGeom>
             <a:avLst/>
@@ -14870,28 +14901,33 @@
             <a:cxnLst/>
             <a:rect r="r" b="b" t="t" l="l"/>
             <a:pathLst>
-              <a:path h="1962470" w="5165664">
+              <a:path h="1588300" w="4856348">
                 <a:moveTo>
                   <a:pt x="0" y="0"/>
                 </a:moveTo>
                 <a:lnTo>
-                  <a:pt x="2354232" y="0"/>
+                  <a:pt x="2199574" y="0"/>
                 </a:lnTo>
                 <a:cubicBezTo>
-                  <a:pt x="2480484" y="0"/>
-                  <a:pt x="2582832" y="102348"/>
-                  <a:pt x="2582832" y="228600"/>
+                  <a:pt x="2260203" y="0"/>
+                  <a:pt x="2318348" y="24085"/>
+                  <a:pt x="2361218" y="66956"/>
                 </a:cubicBezTo>
-                <a:lnTo>
-                  <a:pt x="2582832" y="1733870"/>
-                </a:lnTo>
                 <a:cubicBezTo>
-                  <a:pt x="2582832" y="1860122"/>
-                  <a:pt x="2685180" y="1962470"/>
-                  <a:pt x="2811432" y="1962470"/>
+                  <a:pt x="2404089" y="109827"/>
+                  <a:pt x="2428174" y="167972"/>
+                  <a:pt x="2428174" y="228600"/>
                 </a:cubicBezTo>
                 <a:lnTo>
-                  <a:pt x="5165664" y="1962470"/>
+                  <a:pt x="2428174" y="1359700"/>
+                </a:lnTo>
+                <a:cubicBezTo>
+                  <a:pt x="2428174" y="1485952"/>
+                  <a:pt x="2530522" y="1588300"/>
+                  <a:pt x="2656774" y="1588300"/>
+                </a:cubicBezTo>
+                <a:lnTo>
+                  <a:pt x="4856348" y="1588300"/>
                 </a:lnTo>
               </a:path>
             </a:pathLst>
@@ -14914,8 +14950,8 @@
         </p:nvSpPr>
         <p:spPr>
           <a:xfrm rot="0">
-            <a:off x="2291504" y="4361016"/>
-            <a:ext cx="3086100" cy="481331"/>
+            <a:off x="1638484" y="4385944"/>
+            <a:ext cx="3086100" cy="613411"/>
           </a:xfrm>
           <a:prstGeom prst="rect">
             <a:avLst/>
@@ -14929,14 +14965,14 @@
           <a:p>
             <a:pPr algn="ctr">
               <a:lnSpc>
-                <a:spcPts val="3919"/>
+                <a:spcPts val="5039"/>
               </a:lnSpc>
               <a:spcBef>
                 <a:spcPct val="0"/>
               </a:spcBef>
             </a:pPr>
             <a:r>
-              <a:rPr lang="en-US" sz="2799">
+              <a:rPr lang="en-US" sz="3599">
                 <a:solidFill>
                   <a:srgbClr val="000000"/>
                 </a:solidFill>
@@ -14958,8 +14994,8 @@
         </p:nvSpPr>
         <p:spPr>
           <a:xfrm rot="0">
-            <a:off x="2291504" y="5135264"/>
-            <a:ext cx="3086100" cy="448311"/>
+            <a:off x="665085" y="5454875"/>
+            <a:ext cx="5021835" cy="1362711"/>
           </a:xfrm>
           <a:prstGeom prst="rect">
             <a:avLst/>
@@ -14971,13 +15007,12 @@
           </a:bodyPr>
           <a:lstStyle/>
           <a:p>
-            <a:pPr algn="ctr">
+            <a:pPr algn="l" marL="561336" indent="-280668" lvl="1">
               <a:lnSpc>
                 <a:spcPts val="3639"/>
               </a:lnSpc>
-              <a:spcBef>
-                <a:spcPct val="0"/>
-              </a:spcBef>
+              <a:buFont typeface="Arial"/>
+              <a:buChar char="•"/>
             </a:pPr>
             <a:r>
               <a:rPr lang="en-US" sz="2599">
@@ -14989,39 +15024,16 @@
                 <a:cs typeface="Noto Sans"/>
                 <a:sym typeface="Noto Sans"/>
               </a:rPr>
-              <a:t>HTML/CSS/JS</a:t>
+              <a:t>HTML/CSS/JavaScript</a:t>
             </a:r>
           </a:p>
-        </p:txBody>
-      </p:sp>
-      <p:sp>
-        <p:nvSpPr>
-          <p:cNvPr name="TextBox 20" id="20"/>
-          <p:cNvSpPr txBox="true"/>
-          <p:nvPr/>
-        </p:nvSpPr>
-        <p:spPr>
-          <a:xfrm rot="0">
-            <a:off x="2291504" y="5771330"/>
-            <a:ext cx="3086100" cy="1362711"/>
-          </a:xfrm>
-          <a:prstGeom prst="rect">
-            <a:avLst/>
-          </a:prstGeom>
-        </p:spPr>
-        <p:txBody>
-          <a:bodyPr anchor="t" rtlCol="false" tIns="0" lIns="0" bIns="0" rIns="0">
-            <a:spAutoFit/>
-          </a:bodyPr>
-          <a:lstStyle/>
           <a:p>
-            <a:pPr algn="ctr">
+            <a:pPr algn="l" marL="561336" indent="-280668" lvl="1">
               <a:lnSpc>
                 <a:spcPts val="3639"/>
               </a:lnSpc>
-              <a:spcBef>
-                <a:spcPct val="0"/>
-              </a:spcBef>
+              <a:buFont typeface="Arial"/>
+              <a:buChar char="•"/>
             </a:pPr>
             <a:r>
               <a:rPr lang="en-US" sz="2599">
@@ -15040,7 +15052,7 @@
       </p:sp>
       <p:sp>
         <p:nvSpPr>
-          <p:cNvPr name="TextBox 21" id="21"/>
+          <p:cNvPr name="TextBox 20" id="20"/>
           <p:cNvSpPr txBox="true"/>
           <p:nvPr/>
         </p:nvSpPr>
@@ -15084,7 +15096,7 @@
       </p:sp>
       <p:sp>
         <p:nvSpPr>
-          <p:cNvPr name="TextBox 22" id="22"/>
+          <p:cNvPr name="TextBox 21" id="21"/>
           <p:cNvSpPr txBox="true"/>
           <p:nvPr/>
         </p:nvSpPr>
@@ -15190,7 +15202,7 @@
       </p:sp>
       <p:sp>
         <p:nvSpPr>
-          <p:cNvPr name="AutoShape 23" id="23"/>
+          <p:cNvPr name="AutoShape 22" id="22"/>
           <p:cNvSpPr/>
           <p:nvPr/>
         </p:nvSpPr>
@@ -15214,7 +15226,7 @@
       </p:sp>
       <p:sp>
         <p:nvSpPr>
-          <p:cNvPr name="AutoShape 24" id="24"/>
+          <p:cNvPr name="AutoShape 23" id="23"/>
           <p:cNvSpPr/>
           <p:nvPr/>
         </p:nvSpPr>
@@ -15238,7 +15250,7 @@
       </p:sp>
       <p:sp>
         <p:nvSpPr>
-          <p:cNvPr name="TextBox 25" id="25"/>
+          <p:cNvPr name="TextBox 24" id="24"/>
           <p:cNvSpPr txBox="true"/>
           <p:nvPr/>
         </p:nvSpPr>
@@ -15282,7 +15294,7 @@
       </p:sp>
       <p:sp>
         <p:nvSpPr>
-          <p:cNvPr name="TextBox 26" id="26"/>
+          <p:cNvPr name="TextBox 25" id="25"/>
           <p:cNvSpPr txBox="true"/>
           <p:nvPr/>
         </p:nvSpPr>
@@ -15346,14 +15358,14 @@
       </p:sp>
       <p:sp>
         <p:nvSpPr>
-          <p:cNvPr name="AutoShape 27" id="27"/>
+          <p:cNvPr name="AutoShape 26" id="26"/>
           <p:cNvSpPr/>
           <p:nvPr/>
         </p:nvSpPr>
         <p:spPr>
           <a:xfrm>
-            <a:off x="2291504" y="4925714"/>
-            <a:ext cx="3086100" cy="0"/>
+            <a:off x="831407" y="5143500"/>
+            <a:ext cx="4833630" cy="0"/>
           </a:xfrm>
           <a:prstGeom prst="line">
             <a:avLst/>

</xml_diff>